<commit_message>
Switch the subagent slide to a white-based palette
Both the HTML slide and the PowerPoint version now sit on white instead of the
dark navy ground, for printing and for projectors in lit rooms.

- Ground: white slide on a light grey page; stage panels and takeaway cards use
  a near-white cool grey with hairline borders
- Accents darkened for contrast on white: orange F26430 -> D9531E, and the
  subagent cyan 5FC6D8 -> teal 0E7A90 with a lighter 6FB3C4 for card borders
- Text: deep navy 10294D for headings, 44566F for body, 6B7D95 for captions

Structure, wording and geometry are unchanged.

Co-Authored-By: Claude Opus 5 <noreply@anthropic.com>
Claude-Session: https://claude.ai/code/session_01BpPDMjv83khVU7DTgETnPC
</commit_message>
<xml_diff>
--- a/subagent-slide.pptx
+++ b/subagent-slide.pptx
@@ -860,7 +860,7 @@
     <p:bg>
       <p:bgPr>
         <a:solidFill>
-          <a:srgbClr val="13294C"/>
+          <a:srgbClr val="FFFFFF"/>
         </a:solidFill>
       </p:bgPr>
     </p:bg>
@@ -905,7 +905,7 @@
             <a:r>
               <a:rPr lang="en-US" sz="1000" b="1" spc="300" kern="0" dirty="0">
                 <a:solidFill>
-                  <a:srgbClr val="FFB27A"/>
+                  <a:srgbClr val="B8481B"/>
                 </a:solidFill>
                 <a:latin typeface="Arial" pitchFamily="34" charset="0"/>
                 <a:ea typeface="Arial" pitchFamily="34" charset="-122"/>
@@ -944,7 +944,7 @@
             <a:r>
               <a:rPr lang="en-US" sz="3600" b="1" dirty="0">
                 <a:solidFill>
-                  <a:srgbClr val="EEF4FA"/>
+                  <a:srgbClr val="10294D"/>
                 </a:solidFill>
                 <a:latin typeface="Yu Gothic" pitchFamily="34" charset="0"/>
                 <a:ea typeface="Yu Gothic" pitchFamily="34" charset="-122"/>
@@ -958,7 +958,7 @@
             <a:r>
               <a:rPr lang="en-US" sz="3600" b="1" dirty="0">
                 <a:solidFill>
-                  <a:srgbClr val="F26430"/>
+                  <a:srgbClr val="D9531E"/>
                 </a:solidFill>
                 <a:latin typeface="Yu Gothic" pitchFamily="34" charset="0"/>
                 <a:ea typeface="Yu Gothic" pitchFamily="34" charset="-122"/>
@@ -997,7 +997,7 @@
             <a:r>
               <a:rPr lang="en-US" sz="1000" b="1" dirty="0">
                 <a:solidFill>
-                  <a:srgbClr val="FFB27A"/>
+                  <a:srgbClr val="B8481B"/>
                 </a:solidFill>
                 <a:latin typeface="Yu Gothic" pitchFamily="34" charset="0"/>
                 <a:ea typeface="Yu Gothic" pitchFamily="34" charset="-122"/>
@@ -1039,7 +1039,7 @@
             <a:r>
               <a:rPr lang="en-US" sz="1200" dirty="0">
                 <a:solidFill>
-                  <a:srgbClr val="EEF4FA"/>
+                  <a:srgbClr val="44566F"/>
                 </a:solidFill>
                 <a:latin typeface="Yu Gothic" pitchFamily="34" charset="0"/>
                 <a:ea typeface="Yu Gothic" pitchFamily="34" charset="-122"/>
@@ -1056,7 +1056,7 @@
             <a:r>
               <a:rPr lang="en-US" sz="1200" b="1" dirty="0">
                 <a:solidFill>
-                  <a:srgbClr val="FFB27A"/>
+                  <a:srgbClr val="B8481B"/>
                 </a:solidFill>
                 <a:latin typeface="Yu Gothic" pitchFamily="34" charset="0"/>
                 <a:ea typeface="Yu Gothic" pitchFamily="34" charset="-122"/>
@@ -1073,7 +1073,7 @@
             <a:r>
               <a:rPr lang="en-US" sz="1200" dirty="0">
                 <a:solidFill>
-                  <a:srgbClr val="EEF4FA"/>
+                  <a:srgbClr val="44566F"/>
                 </a:solidFill>
                 <a:latin typeface="Yu Gothic" pitchFamily="34" charset="0"/>
                 <a:ea typeface="Yu Gothic" pitchFamily="34" charset="-122"/>
@@ -1090,7 +1090,7 @@
             <a:r>
               <a:rPr lang="en-US" sz="1200" b="1" dirty="0">
                 <a:solidFill>
-                  <a:srgbClr val="FFB27A"/>
+                  <a:srgbClr val="B8481B"/>
                 </a:solidFill>
                 <a:latin typeface="Yu Gothic" pitchFamily="34" charset="0"/>
                 <a:ea typeface="Yu Gothic" pitchFamily="34" charset="-122"/>
@@ -1107,7 +1107,7 @@
             <a:r>
               <a:rPr lang="en-US" sz="1200" dirty="0">
                 <a:solidFill>
-                  <a:srgbClr val="EEF4FA"/>
+                  <a:srgbClr val="44566F"/>
                 </a:solidFill>
                 <a:latin typeface="Yu Gothic" pitchFamily="34" charset="0"/>
                 <a:ea typeface="Yu Gothic" pitchFamily="34" charset="-122"/>
@@ -1136,11 +1136,11 @@
             </a:avLst>
           </a:prstGeom>
           <a:solidFill>
-            <a:srgbClr val="17305A"/>
+            <a:srgbClr val="F6F8FB"/>
           </a:solidFill>
           <a:ln w="12700">
             <a:solidFill>
-              <a:srgbClr val="2B4C82"/>
+              <a:srgbClr val="DDE5EF"/>
             </a:solidFill>
             <a:prstDash val="solid"/>
           </a:ln>
@@ -1173,7 +1173,7 @@
             <a:r>
               <a:rPr lang="en-US" sz="1200" b="1" dirty="0">
                 <a:solidFill>
-                  <a:srgbClr val="F26430"/>
+                  <a:srgbClr val="D9531E"/>
                 </a:solidFill>
                 <a:latin typeface="Arial" pitchFamily="34" charset="0"/>
                 <a:ea typeface="Arial" pitchFamily="34" charset="-122"/>
@@ -1187,7 +1187,7 @@
             <a:r>
               <a:rPr lang="en-US" sz="1200" b="1" dirty="0">
                 <a:solidFill>
-                  <a:srgbClr val="EEF4FA"/>
+                  <a:srgbClr val="10294D"/>
                 </a:solidFill>
                 <a:latin typeface="Yu Gothic" pitchFamily="34" charset="0"/>
                 <a:ea typeface="Yu Gothic" pitchFamily="34" charset="-122"/>
@@ -1216,11 +1216,11 @@
             </a:avLst>
           </a:prstGeom>
           <a:solidFill>
-            <a:srgbClr val="17305A"/>
+            <a:srgbClr val="F6F8FB"/>
           </a:solidFill>
           <a:ln w="12700">
             <a:solidFill>
-              <a:srgbClr val="2B4C82"/>
+              <a:srgbClr val="DDE5EF"/>
             </a:solidFill>
             <a:prstDash val="solid"/>
           </a:ln>
@@ -1253,7 +1253,7 @@
             <a:r>
               <a:rPr lang="en-US" sz="1200" b="1" dirty="0">
                 <a:solidFill>
-                  <a:srgbClr val="F26430"/>
+                  <a:srgbClr val="D9531E"/>
                 </a:solidFill>
                 <a:latin typeface="Arial" pitchFamily="34" charset="0"/>
                 <a:ea typeface="Arial" pitchFamily="34" charset="-122"/>
@@ -1267,7 +1267,7 @@
             <a:r>
               <a:rPr lang="en-US" sz="1200" b="1" dirty="0">
                 <a:solidFill>
-                  <a:srgbClr val="EEF4FA"/>
+                  <a:srgbClr val="10294D"/>
                 </a:solidFill>
                 <a:latin typeface="Yu Gothic" pitchFamily="34" charset="0"/>
                 <a:ea typeface="Yu Gothic" pitchFamily="34" charset="-122"/>
@@ -1296,11 +1296,11 @@
             </a:avLst>
           </a:prstGeom>
           <a:solidFill>
-            <a:srgbClr val="17305A"/>
+            <a:srgbClr val="F6F8FB"/>
           </a:solidFill>
           <a:ln w="12700">
             <a:solidFill>
-              <a:srgbClr val="2B4C82"/>
+              <a:srgbClr val="DDE5EF"/>
             </a:solidFill>
             <a:prstDash val="solid"/>
           </a:ln>
@@ -1333,7 +1333,7 @@
             <a:r>
               <a:rPr lang="en-US" sz="1200" b="1" dirty="0">
                 <a:solidFill>
-                  <a:srgbClr val="F26430"/>
+                  <a:srgbClr val="D9531E"/>
                 </a:solidFill>
                 <a:latin typeface="Arial" pitchFamily="34" charset="0"/>
                 <a:ea typeface="Arial" pitchFamily="34" charset="-122"/>
@@ -1347,7 +1347,7 @@
             <a:r>
               <a:rPr lang="en-US" sz="1200" b="1" dirty="0">
                 <a:solidFill>
-                  <a:srgbClr val="EEF4FA"/>
+                  <a:srgbClr val="10294D"/>
                 </a:solidFill>
                 <a:latin typeface="Yu Gothic" pitchFamily="34" charset="0"/>
                 <a:ea typeface="Yu Gothic" pitchFamily="34" charset="-122"/>
@@ -1376,11 +1376,11 @@
             </a:avLst>
           </a:prstGeom>
           <a:solidFill>
-            <a:srgbClr val="1D3563"/>
-          </a:solidFill>
-          <a:ln w="12700">
+            <a:srgbClr val="FFFFFF"/>
+          </a:solidFill>
+          <a:ln w="15875">
             <a:solidFill>
-              <a:srgbClr val="7E9BC4"/>
+              <a:srgbClr val="B9C7D9"/>
             </a:solidFill>
             <a:prstDash val="solid"/>
           </a:ln>
@@ -1413,7 +1413,7 @@
             <a:r>
               <a:rPr lang="en-US" sz="1200" b="1" dirty="0">
                 <a:solidFill>
-                  <a:srgbClr val="EEF4FA"/>
+                  <a:srgbClr val="10294D"/>
                 </a:solidFill>
                 <a:latin typeface="Yu Gothic" pitchFamily="34" charset="0"/>
                 <a:ea typeface="Yu Gothic" pitchFamily="34" charset="-122"/>
@@ -1442,7 +1442,7 @@
           <a:noFill/>
           <a:ln w="19050">
             <a:solidFill>
-              <a:srgbClr val="EEF4FA"/>
+              <a:srgbClr val="8A9BB0"/>
             </a:solidFill>
             <a:prstDash val="solid"/>
             <a:tailEnd type="triangle"/>
@@ -1466,11 +1466,11 @@
             </a:avLst>
           </a:prstGeom>
           <a:solidFill>
-            <a:srgbClr val="24365C"/>
+            <a:srgbClr val="FFF3EC"/>
           </a:solidFill>
           <a:ln w="19050">
             <a:solidFill>
-              <a:srgbClr val="F26430"/>
+              <a:srgbClr val="D9531E"/>
             </a:solidFill>
             <a:prstDash val="solid"/>
           </a:ln>
@@ -1503,7 +1503,7 @@
             <a:r>
               <a:rPr lang="en-US" sz="1600" b="1" dirty="0">
                 <a:solidFill>
-                  <a:srgbClr val="EEF4FA"/>
+                  <a:srgbClr val="10294D"/>
                 </a:solidFill>
                 <a:latin typeface="Yu Gothic" pitchFamily="34" charset="0"/>
                 <a:ea typeface="Yu Gothic" pitchFamily="34" charset="-122"/>
@@ -1542,7 +1542,7 @@
             <a:r>
               <a:rPr lang="en-US" sz="1000" dirty="0">
                 <a:solidFill>
-                  <a:srgbClr val="FFB27A"/>
+                  <a:srgbClr val="B8481B"/>
                 </a:solidFill>
                 <a:latin typeface="Yu Gothic" pitchFamily="34" charset="0"/>
                 <a:ea typeface="Yu Gothic" pitchFamily="34" charset="-122"/>
@@ -1584,7 +1584,7 @@
             <a:r>
               <a:rPr lang="en-US" sz="900" dirty="0">
                 <a:solidFill>
-                  <a:srgbClr val="B9C7DA"/>
+                  <a:srgbClr val="6B7D95"/>
                 </a:solidFill>
                 <a:latin typeface="Yu Gothic" pitchFamily="34" charset="0"/>
                 <a:ea typeface="Yu Gothic" pitchFamily="34" charset="-122"/>
@@ -1604,7 +1604,7 @@
             <a:r>
               <a:rPr lang="en-US" sz="900" dirty="0">
                 <a:solidFill>
-                  <a:srgbClr val="B9C7DA"/>
+                  <a:srgbClr val="6B7D95"/>
                 </a:solidFill>
                 <a:latin typeface="Yu Gothic" pitchFamily="34" charset="0"/>
                 <a:ea typeface="Yu Gothic" pitchFamily="34" charset="-122"/>
@@ -1643,7 +1643,7 @@
             <a:r>
               <a:rPr lang="en-US" sz="1000" dirty="0">
                 <a:solidFill>
-                  <a:srgbClr val="B9C7DA"/>
+                  <a:srgbClr val="6B7D95"/>
                 </a:solidFill>
                 <a:latin typeface="Yu Gothic" pitchFamily="34" charset="0"/>
                 <a:ea typeface="Yu Gothic" pitchFamily="34" charset="-122"/>
@@ -1672,7 +1672,7 @@
           <a:noFill/>
           <a:ln w="25400">
             <a:solidFill>
-              <a:srgbClr val="F26430"/>
+              <a:srgbClr val="D9531E"/>
             </a:solidFill>
             <a:prstDash val="solid"/>
             <a:tailEnd type="triangle"/>
@@ -1696,7 +1696,7 @@
           <a:noFill/>
           <a:ln w="25400">
             <a:solidFill>
-              <a:srgbClr val="F26430"/>
+              <a:srgbClr val="D9531E"/>
             </a:solidFill>
             <a:prstDash val="solid"/>
             <a:tailEnd type="triangle"/>
@@ -1720,7 +1720,7 @@
           <a:noFill/>
           <a:ln w="25400">
             <a:solidFill>
-              <a:srgbClr val="F26430"/>
+              <a:srgbClr val="D9531E"/>
             </a:solidFill>
             <a:prstDash val="solid"/>
             <a:tailEnd type="triangle"/>
@@ -1744,11 +1744,11 @@
             </a:avLst>
           </a:prstGeom>
           <a:solidFill>
-            <a:srgbClr val="1B395A"/>
-          </a:solidFill>
-          <a:ln w="15875">
+            <a:srgbClr val="F0F8FB"/>
+          </a:solidFill>
+          <a:ln w="19050">
             <a:solidFill>
-              <a:srgbClr val="5FC6D8"/>
+              <a:srgbClr val="6FB3C4"/>
             </a:solidFill>
             <a:prstDash val="solid"/>
           </a:ln>
@@ -1769,11 +1769,11 @@
             <a:avLst/>
           </a:prstGeom>
           <a:solidFill>
-            <a:srgbClr val="235071"/>
+            <a:srgbClr val="E4F2F6"/>
           </a:solidFill>
           <a:ln w="15875">
             <a:solidFill>
-              <a:srgbClr val="5FC6D8"/>
+              <a:srgbClr val="6FB3C4"/>
             </a:solidFill>
             <a:prstDash val="solid"/>
           </a:ln>
@@ -1806,7 +1806,7 @@
             <a:r>
               <a:rPr lang="en-US" sz="1200" b="1" dirty="0">
                 <a:solidFill>
-                  <a:srgbClr val="5FC6D8"/>
+                  <a:srgbClr val="0E7A90"/>
                 </a:solidFill>
                 <a:latin typeface="Yu Gothic" pitchFamily="34" charset="0"/>
                 <a:ea typeface="Yu Gothic" pitchFamily="34" charset="-122"/>
@@ -1845,7 +1845,7 @@
             <a:r>
               <a:rPr lang="en-US" sz="1200" b="1" dirty="0">
                 <a:solidFill>
-                  <a:srgbClr val="EEF4FA"/>
+                  <a:srgbClr val="10294D"/>
                 </a:solidFill>
                 <a:latin typeface="Yu Gothic" pitchFamily="34" charset="0"/>
                 <a:ea typeface="Yu Gothic" pitchFamily="34" charset="-122"/>
@@ -1884,7 +1884,7 @@
             <a:r>
               <a:rPr lang="en-US" sz="900" dirty="0">
                 <a:solidFill>
-                  <a:srgbClr val="B9C7DA"/>
+                  <a:srgbClr val="6B7D95"/>
                 </a:solidFill>
                 <a:latin typeface="Yu Gothic" pitchFamily="34" charset="0"/>
                 <a:ea typeface="Yu Gothic" pitchFamily="34" charset="-122"/>
@@ -1914,7 +1914,7 @@
           </a:prstGeom>
           <a:ln w="9525">
             <a:solidFill>
-              <a:srgbClr val="5FC6D8"/>
+              <a:srgbClr val="6FB3C4"/>
             </a:solidFill>
             <a:prstDash val="dash"/>
           </a:ln>
@@ -1947,7 +1947,7 @@
             <a:r>
               <a:rPr lang="en-US" sz="800" dirty="0">
                 <a:solidFill>
-                  <a:srgbClr val="5FC6D8"/>
+                  <a:srgbClr val="0E7A90"/>
                 </a:solidFill>
                 <a:latin typeface="Yu Gothic" pitchFamily="34" charset="0"/>
                 <a:ea typeface="Yu Gothic" pitchFamily="34" charset="-122"/>
@@ -1976,11 +1976,11 @@
             </a:avLst>
           </a:prstGeom>
           <a:solidFill>
-            <a:srgbClr val="1B395A"/>
-          </a:solidFill>
-          <a:ln w="15875">
+            <a:srgbClr val="F0F8FB"/>
+          </a:solidFill>
+          <a:ln w="19050">
             <a:solidFill>
-              <a:srgbClr val="5FC6D8"/>
+              <a:srgbClr val="6FB3C4"/>
             </a:solidFill>
             <a:prstDash val="solid"/>
           </a:ln>
@@ -2001,11 +2001,11 @@
             <a:avLst/>
           </a:prstGeom>
           <a:solidFill>
-            <a:srgbClr val="235071"/>
+            <a:srgbClr val="E4F2F6"/>
           </a:solidFill>
           <a:ln w="15875">
             <a:solidFill>
-              <a:srgbClr val="5FC6D8"/>
+              <a:srgbClr val="6FB3C4"/>
             </a:solidFill>
             <a:prstDash val="solid"/>
           </a:ln>
@@ -2038,7 +2038,7 @@
             <a:r>
               <a:rPr lang="en-US" sz="1200" b="1" dirty="0">
                 <a:solidFill>
-                  <a:srgbClr val="5FC6D8"/>
+                  <a:srgbClr val="0E7A90"/>
                 </a:solidFill>
                 <a:latin typeface="Yu Gothic" pitchFamily="34" charset="0"/>
                 <a:ea typeface="Yu Gothic" pitchFamily="34" charset="-122"/>
@@ -2077,7 +2077,7 @@
             <a:r>
               <a:rPr lang="en-US" sz="1200" b="1" dirty="0">
                 <a:solidFill>
-                  <a:srgbClr val="EEF4FA"/>
+                  <a:srgbClr val="10294D"/>
                 </a:solidFill>
                 <a:latin typeface="Yu Gothic" pitchFamily="34" charset="0"/>
                 <a:ea typeface="Yu Gothic" pitchFamily="34" charset="-122"/>
@@ -2116,7 +2116,7 @@
             <a:r>
               <a:rPr lang="en-US" sz="900" dirty="0">
                 <a:solidFill>
-                  <a:srgbClr val="B9C7DA"/>
+                  <a:srgbClr val="6B7D95"/>
                 </a:solidFill>
                 <a:latin typeface="Yu Gothic" pitchFamily="34" charset="0"/>
                 <a:ea typeface="Yu Gothic" pitchFamily="34" charset="-122"/>
@@ -2146,7 +2146,7 @@
           </a:prstGeom>
           <a:ln w="9525">
             <a:solidFill>
-              <a:srgbClr val="5FC6D8"/>
+              <a:srgbClr val="6FB3C4"/>
             </a:solidFill>
             <a:prstDash val="dash"/>
           </a:ln>
@@ -2179,7 +2179,7 @@
             <a:r>
               <a:rPr lang="en-US" sz="800" dirty="0">
                 <a:solidFill>
-                  <a:srgbClr val="5FC6D8"/>
+                  <a:srgbClr val="0E7A90"/>
                 </a:solidFill>
                 <a:latin typeface="Yu Gothic" pitchFamily="34" charset="0"/>
                 <a:ea typeface="Yu Gothic" pitchFamily="34" charset="-122"/>
@@ -2208,11 +2208,11 @@
             </a:avLst>
           </a:prstGeom>
           <a:solidFill>
-            <a:srgbClr val="1B395A"/>
-          </a:solidFill>
-          <a:ln w="15875">
+            <a:srgbClr val="F0F8FB"/>
+          </a:solidFill>
+          <a:ln w="19050">
             <a:solidFill>
-              <a:srgbClr val="5FC6D8"/>
+              <a:srgbClr val="6FB3C4"/>
             </a:solidFill>
             <a:prstDash val="solid"/>
           </a:ln>
@@ -2233,11 +2233,11 @@
             <a:avLst/>
           </a:prstGeom>
           <a:solidFill>
-            <a:srgbClr val="235071"/>
+            <a:srgbClr val="E4F2F6"/>
           </a:solidFill>
           <a:ln w="15875">
             <a:solidFill>
-              <a:srgbClr val="5FC6D8"/>
+              <a:srgbClr val="6FB3C4"/>
             </a:solidFill>
             <a:prstDash val="solid"/>
           </a:ln>
@@ -2270,7 +2270,7 @@
             <a:r>
               <a:rPr lang="en-US" sz="1200" b="1" dirty="0">
                 <a:solidFill>
-                  <a:srgbClr val="5FC6D8"/>
+                  <a:srgbClr val="0E7A90"/>
                 </a:solidFill>
                 <a:latin typeface="Yu Gothic" pitchFamily="34" charset="0"/>
                 <a:ea typeface="Yu Gothic" pitchFamily="34" charset="-122"/>
@@ -2309,7 +2309,7 @@
             <a:r>
               <a:rPr lang="en-US" sz="1200" b="1" dirty="0">
                 <a:solidFill>
-                  <a:srgbClr val="EEF4FA"/>
+                  <a:srgbClr val="10294D"/>
                 </a:solidFill>
                 <a:latin typeface="Yu Gothic" pitchFamily="34" charset="0"/>
                 <a:ea typeface="Yu Gothic" pitchFamily="34" charset="-122"/>
@@ -2348,7 +2348,7 @@
             <a:r>
               <a:rPr lang="en-US" sz="900" dirty="0">
                 <a:solidFill>
-                  <a:srgbClr val="B9C7DA"/>
+                  <a:srgbClr val="6B7D95"/>
                 </a:solidFill>
                 <a:latin typeface="Yu Gothic" pitchFamily="34" charset="0"/>
                 <a:ea typeface="Yu Gothic" pitchFamily="34" charset="-122"/>
@@ -2378,7 +2378,7 @@
           </a:prstGeom>
           <a:ln w="9525">
             <a:solidFill>
-              <a:srgbClr val="5FC6D8"/>
+              <a:srgbClr val="6FB3C4"/>
             </a:solidFill>
             <a:prstDash val="dash"/>
           </a:ln>
@@ -2411,7 +2411,7 @@
             <a:r>
               <a:rPr lang="en-US" sz="800" dirty="0">
                 <a:solidFill>
-                  <a:srgbClr val="5FC6D8"/>
+                  <a:srgbClr val="0E7A90"/>
                 </a:solidFill>
                 <a:latin typeface="Yu Gothic" pitchFamily="34" charset="0"/>
                 <a:ea typeface="Yu Gothic" pitchFamily="34" charset="-122"/>
@@ -2450,7 +2450,7 @@
             <a:r>
               <a:rPr lang="en-US" sz="1000" b="1" dirty="0">
                 <a:solidFill>
-                  <a:srgbClr val="5FC6D8"/>
+                  <a:srgbClr val="0E7A90"/>
                 </a:solidFill>
                 <a:latin typeface="Yu Gothic" pitchFamily="34" charset="0"/>
                 <a:ea typeface="Yu Gothic" pitchFamily="34" charset="-122"/>
@@ -2479,7 +2479,7 @@
           <a:noFill/>
           <a:ln w="25400">
             <a:solidFill>
-              <a:srgbClr val="5FC6D8"/>
+              <a:srgbClr val="0E7A90"/>
             </a:solidFill>
             <a:prstDash val="solid"/>
             <a:tailEnd type="triangle"/>
@@ -2503,7 +2503,7 @@
           <a:noFill/>
           <a:ln w="25400">
             <a:solidFill>
-              <a:srgbClr val="5FC6D8"/>
+              <a:srgbClr val="0E7A90"/>
             </a:solidFill>
             <a:prstDash val="solid"/>
             <a:tailEnd type="triangle"/>
@@ -2527,7 +2527,7 @@
           <a:noFill/>
           <a:ln w="25400">
             <a:solidFill>
-              <a:srgbClr val="5FC6D8"/>
+              <a:srgbClr val="0E7A90"/>
             </a:solidFill>
             <a:prstDash val="solid"/>
             <a:tailEnd type="triangle"/>
@@ -2551,11 +2551,11 @@
             </a:avLst>
           </a:prstGeom>
           <a:solidFill>
-            <a:srgbClr val="24365C"/>
+            <a:srgbClr val="FFF3EC"/>
           </a:solidFill>
           <a:ln w="19050">
             <a:solidFill>
-              <a:srgbClr val="F26430"/>
+              <a:srgbClr val="D9531E"/>
             </a:solidFill>
             <a:prstDash val="solid"/>
           </a:ln>
@@ -2588,7 +2588,7 @@
             <a:r>
               <a:rPr lang="en-US" sz="1400" b="1" dirty="0">
                 <a:solidFill>
-                  <a:srgbClr val="EEF4FA"/>
+                  <a:srgbClr val="10294D"/>
                 </a:solidFill>
                 <a:latin typeface="Yu Gothic" pitchFamily="34" charset="0"/>
                 <a:ea typeface="Yu Gothic" pitchFamily="34" charset="-122"/>
@@ -2627,7 +2627,7 @@
             <a:r>
               <a:rPr lang="en-US" sz="1000" dirty="0">
                 <a:solidFill>
-                  <a:srgbClr val="FFB27A"/>
+                  <a:srgbClr val="B8481B"/>
                 </a:solidFill>
                 <a:latin typeface="Yu Gothic" pitchFamily="34" charset="0"/>
                 <a:ea typeface="Yu Gothic" pitchFamily="34" charset="-122"/>
@@ -2666,7 +2666,7 @@
             <a:r>
               <a:rPr lang="en-US" sz="900" dirty="0">
                 <a:solidFill>
-                  <a:srgbClr val="B9C7DA"/>
+                  <a:srgbClr val="6B7D95"/>
                 </a:solidFill>
                 <a:latin typeface="Yu Gothic" pitchFamily="34" charset="0"/>
                 <a:ea typeface="Yu Gothic" pitchFamily="34" charset="-122"/>
@@ -2705,7 +2705,7 @@
             <a:r>
               <a:rPr lang="en-US" sz="1000" b="1" dirty="0">
                 <a:solidFill>
-                  <a:srgbClr val="FFB27A"/>
+                  <a:srgbClr val="B8481B"/>
                 </a:solidFill>
                 <a:latin typeface="Yu Gothic" pitchFamily="34" charset="0"/>
                 <a:ea typeface="Yu Gothic" pitchFamily="34" charset="-122"/>
@@ -2744,7 +2744,7 @@
             <a:r>
               <a:rPr lang="en-US" sz="1050" dirty="0">
                 <a:solidFill>
-                  <a:srgbClr val="B9C7DA"/>
+                  <a:srgbClr val="44566F"/>
                 </a:solidFill>
                 <a:latin typeface="Yu Gothic" pitchFamily="34" charset="0"/>
                 <a:ea typeface="Yu Gothic" pitchFamily="34" charset="-122"/>
@@ -2773,11 +2773,11 @@
             </a:avLst>
           </a:prstGeom>
           <a:solidFill>
-            <a:srgbClr val="18325B"/>
+            <a:srgbClr val="F6F8FB"/>
           </a:solidFill>
           <a:ln w="12700">
             <a:solidFill>
-              <a:srgbClr val="2B4C82"/>
+              <a:srgbClr val="DDE5EF"/>
             </a:solidFill>
             <a:prstDash val="solid"/>
           </a:ln>
@@ -2810,7 +2810,7 @@
             <a:r>
               <a:rPr lang="en-US" sz="1000" b="1" dirty="0">
                 <a:solidFill>
-                  <a:srgbClr val="F26430"/>
+                  <a:srgbClr val="D9531E"/>
                 </a:solidFill>
                 <a:latin typeface="Arial" pitchFamily="34" charset="0"/>
                 <a:ea typeface="Arial" pitchFamily="34" charset="-122"/>
@@ -2824,7 +2824,7 @@
             <a:r>
               <a:rPr lang="en-US" sz="1300" b="1" dirty="0">
                 <a:solidFill>
-                  <a:srgbClr val="EEF4FA"/>
+                  <a:srgbClr val="10294D"/>
                 </a:solidFill>
                 <a:latin typeface="Yu Gothic" pitchFamily="34" charset="0"/>
                 <a:ea typeface="Yu Gothic" pitchFamily="34" charset="-122"/>
@@ -2866,7 +2866,7 @@
             <a:r>
               <a:rPr lang="en-US" sz="950" dirty="0">
                 <a:solidFill>
-                  <a:srgbClr val="B9C7DA"/>
+                  <a:srgbClr val="44566F"/>
                 </a:solidFill>
                 <a:latin typeface="Yu Gothic" pitchFamily="34" charset="0"/>
                 <a:ea typeface="Yu Gothic" pitchFamily="34" charset="-122"/>
@@ -2895,11 +2895,11 @@
             </a:avLst>
           </a:prstGeom>
           <a:solidFill>
-            <a:srgbClr val="18325B"/>
+            <a:srgbClr val="F6F8FB"/>
           </a:solidFill>
           <a:ln w="12700">
             <a:solidFill>
-              <a:srgbClr val="2B4C82"/>
+              <a:srgbClr val="DDE5EF"/>
             </a:solidFill>
             <a:prstDash val="solid"/>
           </a:ln>
@@ -2932,7 +2932,7 @@
             <a:r>
               <a:rPr lang="en-US" sz="1000" b="1" dirty="0">
                 <a:solidFill>
-                  <a:srgbClr val="F26430"/>
+                  <a:srgbClr val="D9531E"/>
                 </a:solidFill>
                 <a:latin typeface="Arial" pitchFamily="34" charset="0"/>
                 <a:ea typeface="Arial" pitchFamily="34" charset="-122"/>
@@ -2946,7 +2946,7 @@
             <a:r>
               <a:rPr lang="en-US" sz="1300" b="1" dirty="0">
                 <a:solidFill>
-                  <a:srgbClr val="EEF4FA"/>
+                  <a:srgbClr val="10294D"/>
                 </a:solidFill>
                 <a:latin typeface="Yu Gothic" pitchFamily="34" charset="0"/>
                 <a:ea typeface="Yu Gothic" pitchFamily="34" charset="-122"/>
@@ -2988,7 +2988,7 @@
             <a:r>
               <a:rPr lang="en-US" sz="950" dirty="0">
                 <a:solidFill>
-                  <a:srgbClr val="B9C7DA"/>
+                  <a:srgbClr val="44566F"/>
                 </a:solidFill>
                 <a:latin typeface="Yu Gothic" pitchFamily="34" charset="0"/>
                 <a:ea typeface="Yu Gothic" pitchFamily="34" charset="-122"/>
@@ -3017,11 +3017,11 @@
             </a:avLst>
           </a:prstGeom>
           <a:solidFill>
-            <a:srgbClr val="18325B"/>
+            <a:srgbClr val="F6F8FB"/>
           </a:solidFill>
           <a:ln w="12700">
             <a:solidFill>
-              <a:srgbClr val="2B4C82"/>
+              <a:srgbClr val="DDE5EF"/>
             </a:solidFill>
             <a:prstDash val="solid"/>
           </a:ln>
@@ -3054,7 +3054,7 @@
             <a:r>
               <a:rPr lang="en-US" sz="1000" b="1" dirty="0">
                 <a:solidFill>
-                  <a:srgbClr val="F26430"/>
+                  <a:srgbClr val="D9531E"/>
                 </a:solidFill>
                 <a:latin typeface="Arial" pitchFamily="34" charset="0"/>
                 <a:ea typeface="Arial" pitchFamily="34" charset="-122"/>
@@ -3068,7 +3068,7 @@
             <a:r>
               <a:rPr lang="en-US" sz="1300" b="1" dirty="0">
                 <a:solidFill>
-                  <a:srgbClr val="EEF4FA"/>
+                  <a:srgbClr val="10294D"/>
                 </a:solidFill>
                 <a:latin typeface="Yu Gothic" pitchFamily="34" charset="0"/>
                 <a:ea typeface="Yu Gothic" pitchFamily="34" charset="-122"/>
@@ -3110,7 +3110,7 @@
             <a:r>
               <a:rPr lang="en-US" sz="950" dirty="0">
                 <a:solidFill>
-                  <a:srgbClr val="B9C7DA"/>
+                  <a:srgbClr val="44566F"/>
                 </a:solidFill>
                 <a:latin typeface="Yu Gothic" pitchFamily="34" charset="0"/>
                 <a:ea typeface="Yu Gothic" pitchFamily="34" charset="-122"/>
@@ -3149,7 +3149,7 @@
             <a:r>
               <a:rPr lang="en-US" sz="900" dirty="0">
                 <a:solidFill>
-                  <a:srgbClr val="5E7BA8"/>
+                  <a:srgbClr val="A9B6C7"/>
                 </a:solidFill>
                 <a:latin typeface="Yu Gothic" pitchFamily="34" charset="0"/>
                 <a:ea typeface="Yu Gothic" pitchFamily="34" charset="-122"/>
@@ -3188,7 +3188,7 @@
             <a:r>
               <a:rPr lang="en-US" sz="900" spc="200" kern="0" dirty="0">
                 <a:solidFill>
-                  <a:srgbClr val="5E7BA8"/>
+                  <a:srgbClr val="A9B6C7"/>
                 </a:solidFill>
                 <a:latin typeface="Arial" pitchFamily="34" charset="0"/>
                 <a:ea typeface="Arial" pitchFamily="34" charset="-122"/>

</xml_diff>